<commit_message>
Prints PPTX: add Denmark, Poland, Serbia, Switzerland, Italy (now 10 slides)
Each 120x60mm. Borders/frames trimmed; Serbia (coat of arms) and Switzerland
(centered cross) use edge-stripe extension instead of cropping so nothing is
clipped; others fill edge-to-edge.

Co-Authored-By: Claude Opus 4.8 <noreply@anthropic.com>
Claude-Session: https://claude.ai/code/session_01TnVy1C21x68ctXsvvdvyLV
</commit_message>
<xml_diff>
--- a/print/C-Garden-Prints-120x60mm.pptx
+++ b/print/C-Garden-Prints-120x60mm.pptx
@@ -10,6 +10,11 @@
     <p:sldId id="258" r:id="rId9"/>
     <p:sldId id="259" r:id="rId10"/>
     <p:sldId id="260" r:id="rId11"/>
+    <p:sldId id="261" r:id="rId12"/>
+    <p:sldId id="262" r:id="rId13"/>
+    <p:sldId id="263" r:id="rId14"/>
+    <p:sldId id="264" r:id="rId15"/>
+    <p:sldId id="265" r:id="rId16"/>
   </p:sldIdLst>
   <p:sldSz cx="4320000" cy="2160000" type="screen4x3"/>
   <p:notesSz cx="6858000" cy="9144000"/>
@@ -3124,6 +3129,48 @@
 </p:sld>
 </file>
 
+<file path=ppt/slides/slide10.xml><?xml version="1.0" encoding="utf-8"?>
+<p:sld xmlns:a="http://schemas.openxmlformats.org/drawingml/2006/main" xmlns:p="http://schemas.openxmlformats.org/presentationml/2006/main" xmlns:r="http://schemas.openxmlformats.org/officeDocument/2006/relationships">
+  <p:cSld>
+    <p:spTree>
+      <p:nvGrpSpPr>
+        <p:cNvPr id="1" name=""/>
+        <p:cNvGrpSpPr/>
+        <p:nvPr/>
+      </p:nvGrpSpPr>
+      <p:grpSpPr/>
+      <p:pic>
+        <p:nvPicPr>
+          <p:cNvPr id="2" name="Picture 1" descr="proc_italy.png"/>
+          <p:cNvPicPr>
+            <a:picLocks noChangeAspect="1"/>
+          </p:cNvPicPr>
+          <p:nvPr/>
+        </p:nvPicPr>
+        <p:blipFill>
+          <a:blip r:embed="rId2"/>
+          <a:stretch>
+            <a:fillRect/>
+          </a:stretch>
+        </p:blipFill>
+        <p:spPr>
+          <a:xfrm>
+            <a:off x="0" y="0"/>
+            <a:ext cx="4320000" cy="2160000"/>
+          </a:xfrm>
+          <a:prstGeom prst="rect">
+            <a:avLst/>
+          </a:prstGeom>
+        </p:spPr>
+      </p:pic>
+    </p:spTree>
+  </p:cSld>
+  <p:clrMapOvr>
+    <a:masterClrMapping/>
+  </p:clrMapOvr>
+</p:sld>
+</file>
+
 <file path=ppt/slides/slide2.xml><?xml version="1.0" encoding="utf-8"?>
 <p:sld xmlns:a="http://schemas.openxmlformats.org/drawingml/2006/main" xmlns:p="http://schemas.openxmlformats.org/presentationml/2006/main" xmlns:r="http://schemas.openxmlformats.org/officeDocument/2006/relationships">
   <p:cSld>
@@ -3263,6 +3310,174 @@
       <p:pic>
         <p:nvPicPr>
           <p:cNvPr id="2" name="Picture 1" descr="proc_turkey.png"/>
+          <p:cNvPicPr>
+            <a:picLocks noChangeAspect="1"/>
+          </p:cNvPicPr>
+          <p:nvPr/>
+        </p:nvPicPr>
+        <p:blipFill>
+          <a:blip r:embed="rId2"/>
+          <a:stretch>
+            <a:fillRect/>
+          </a:stretch>
+        </p:blipFill>
+        <p:spPr>
+          <a:xfrm>
+            <a:off x="0" y="0"/>
+            <a:ext cx="4320000" cy="2160000"/>
+          </a:xfrm>
+          <a:prstGeom prst="rect">
+            <a:avLst/>
+          </a:prstGeom>
+        </p:spPr>
+      </p:pic>
+    </p:spTree>
+  </p:cSld>
+  <p:clrMapOvr>
+    <a:masterClrMapping/>
+  </p:clrMapOvr>
+</p:sld>
+</file>
+
+<file path=ppt/slides/slide6.xml><?xml version="1.0" encoding="utf-8"?>
+<p:sld xmlns:a="http://schemas.openxmlformats.org/drawingml/2006/main" xmlns:p="http://schemas.openxmlformats.org/presentationml/2006/main" xmlns:r="http://schemas.openxmlformats.org/officeDocument/2006/relationships">
+  <p:cSld>
+    <p:spTree>
+      <p:nvGrpSpPr>
+        <p:cNvPr id="1" name=""/>
+        <p:cNvGrpSpPr/>
+        <p:nvPr/>
+      </p:nvGrpSpPr>
+      <p:grpSpPr/>
+      <p:pic>
+        <p:nvPicPr>
+          <p:cNvPr id="2" name="Picture 1" descr="proc_denmark.png"/>
+          <p:cNvPicPr>
+            <a:picLocks noChangeAspect="1"/>
+          </p:cNvPicPr>
+          <p:nvPr/>
+        </p:nvPicPr>
+        <p:blipFill>
+          <a:blip r:embed="rId2"/>
+          <a:stretch>
+            <a:fillRect/>
+          </a:stretch>
+        </p:blipFill>
+        <p:spPr>
+          <a:xfrm>
+            <a:off x="0" y="0"/>
+            <a:ext cx="4320000" cy="2160000"/>
+          </a:xfrm>
+          <a:prstGeom prst="rect">
+            <a:avLst/>
+          </a:prstGeom>
+        </p:spPr>
+      </p:pic>
+    </p:spTree>
+  </p:cSld>
+  <p:clrMapOvr>
+    <a:masterClrMapping/>
+  </p:clrMapOvr>
+</p:sld>
+</file>
+
+<file path=ppt/slides/slide7.xml><?xml version="1.0" encoding="utf-8"?>
+<p:sld xmlns:a="http://schemas.openxmlformats.org/drawingml/2006/main" xmlns:p="http://schemas.openxmlformats.org/presentationml/2006/main" xmlns:r="http://schemas.openxmlformats.org/officeDocument/2006/relationships">
+  <p:cSld>
+    <p:spTree>
+      <p:nvGrpSpPr>
+        <p:cNvPr id="1" name=""/>
+        <p:cNvGrpSpPr/>
+        <p:nvPr/>
+      </p:nvGrpSpPr>
+      <p:grpSpPr/>
+      <p:pic>
+        <p:nvPicPr>
+          <p:cNvPr id="2" name="Picture 1" descr="proc_poland.png"/>
+          <p:cNvPicPr>
+            <a:picLocks noChangeAspect="1"/>
+          </p:cNvPicPr>
+          <p:nvPr/>
+        </p:nvPicPr>
+        <p:blipFill>
+          <a:blip r:embed="rId2"/>
+          <a:stretch>
+            <a:fillRect/>
+          </a:stretch>
+        </p:blipFill>
+        <p:spPr>
+          <a:xfrm>
+            <a:off x="0" y="0"/>
+            <a:ext cx="4320000" cy="2160000"/>
+          </a:xfrm>
+          <a:prstGeom prst="rect">
+            <a:avLst/>
+          </a:prstGeom>
+        </p:spPr>
+      </p:pic>
+    </p:spTree>
+  </p:cSld>
+  <p:clrMapOvr>
+    <a:masterClrMapping/>
+  </p:clrMapOvr>
+</p:sld>
+</file>
+
+<file path=ppt/slides/slide8.xml><?xml version="1.0" encoding="utf-8"?>
+<p:sld xmlns:a="http://schemas.openxmlformats.org/drawingml/2006/main" xmlns:p="http://schemas.openxmlformats.org/presentationml/2006/main" xmlns:r="http://schemas.openxmlformats.org/officeDocument/2006/relationships">
+  <p:cSld>
+    <p:spTree>
+      <p:nvGrpSpPr>
+        <p:cNvPr id="1" name=""/>
+        <p:cNvGrpSpPr/>
+        <p:nvPr/>
+      </p:nvGrpSpPr>
+      <p:grpSpPr/>
+      <p:pic>
+        <p:nvPicPr>
+          <p:cNvPr id="2" name="Picture 1" descr="proc_serbia.png"/>
+          <p:cNvPicPr>
+            <a:picLocks noChangeAspect="1"/>
+          </p:cNvPicPr>
+          <p:nvPr/>
+        </p:nvPicPr>
+        <p:blipFill>
+          <a:blip r:embed="rId2"/>
+          <a:stretch>
+            <a:fillRect/>
+          </a:stretch>
+        </p:blipFill>
+        <p:spPr>
+          <a:xfrm>
+            <a:off x="0" y="0"/>
+            <a:ext cx="4320000" cy="2160000"/>
+          </a:xfrm>
+          <a:prstGeom prst="rect">
+            <a:avLst/>
+          </a:prstGeom>
+        </p:spPr>
+      </p:pic>
+    </p:spTree>
+  </p:cSld>
+  <p:clrMapOvr>
+    <a:masterClrMapping/>
+  </p:clrMapOvr>
+</p:sld>
+</file>
+
+<file path=ppt/slides/slide9.xml><?xml version="1.0" encoding="utf-8"?>
+<p:sld xmlns:a="http://schemas.openxmlformats.org/drawingml/2006/main" xmlns:p="http://schemas.openxmlformats.org/presentationml/2006/main" xmlns:r="http://schemas.openxmlformats.org/officeDocument/2006/relationships">
+  <p:cSld>
+    <p:spTree>
+      <p:nvGrpSpPr>
+        <p:cNvPr id="1" name=""/>
+        <p:cNvGrpSpPr/>
+        <p:nvPr/>
+      </p:nvGrpSpPr>
+      <p:grpSpPr/>
+      <p:pic>
+        <p:nvPicPr>
+          <p:cNvPr id="2" name="Picture 1" descr="proc_switzerland.png"/>
           <p:cNvPicPr>
             <a:picLocks noChangeAspect="1"/>
           </p:cNvPicPr>

</xml_diff>

<commit_message>
Prints PPTX: add Belgium, Netherlands, Portugal, Spain, Germany (now 15)
Each 120x60mm; borders trimmed. Portugal and Spain use edge-stripe extension
to keep their coats of arms uncropped; others fill edge-to-edge.

Co-Authored-By: Claude Opus 4.8 <noreply@anthropic.com>
Claude-Session: https://claude.ai/code/session_01TnVy1C21x68ctXsvvdvyLV
</commit_message>
<xml_diff>
--- a/print/C-Garden-Prints-120x60mm.pptx
+++ b/print/C-Garden-Prints-120x60mm.pptx
@@ -15,6 +15,11 @@
     <p:sldId id="263" r:id="rId14"/>
     <p:sldId id="264" r:id="rId15"/>
     <p:sldId id="265" r:id="rId16"/>
+    <p:sldId id="266" r:id="rId17"/>
+    <p:sldId id="267" r:id="rId18"/>
+    <p:sldId id="268" r:id="rId19"/>
+    <p:sldId id="269" r:id="rId20"/>
+    <p:sldId id="270" r:id="rId21"/>
   </p:sldIdLst>
   <p:sldSz cx="4320000" cy="2160000" type="screen4x3"/>
   <p:notesSz cx="6858000" cy="9144000"/>
@@ -3142,6 +3147,216 @@
       <p:pic>
         <p:nvPicPr>
           <p:cNvPr id="2" name="Picture 1" descr="proc_italy.png"/>
+          <p:cNvPicPr>
+            <a:picLocks noChangeAspect="1"/>
+          </p:cNvPicPr>
+          <p:nvPr/>
+        </p:nvPicPr>
+        <p:blipFill>
+          <a:blip r:embed="rId2"/>
+          <a:stretch>
+            <a:fillRect/>
+          </a:stretch>
+        </p:blipFill>
+        <p:spPr>
+          <a:xfrm>
+            <a:off x="0" y="0"/>
+            <a:ext cx="4320000" cy="2160000"/>
+          </a:xfrm>
+          <a:prstGeom prst="rect">
+            <a:avLst/>
+          </a:prstGeom>
+        </p:spPr>
+      </p:pic>
+    </p:spTree>
+  </p:cSld>
+  <p:clrMapOvr>
+    <a:masterClrMapping/>
+  </p:clrMapOvr>
+</p:sld>
+</file>
+
+<file path=ppt/slides/slide11.xml><?xml version="1.0" encoding="utf-8"?>
+<p:sld xmlns:a="http://schemas.openxmlformats.org/drawingml/2006/main" xmlns:p="http://schemas.openxmlformats.org/presentationml/2006/main" xmlns:r="http://schemas.openxmlformats.org/officeDocument/2006/relationships">
+  <p:cSld>
+    <p:spTree>
+      <p:nvGrpSpPr>
+        <p:cNvPr id="1" name=""/>
+        <p:cNvGrpSpPr/>
+        <p:nvPr/>
+      </p:nvGrpSpPr>
+      <p:grpSpPr/>
+      <p:pic>
+        <p:nvPicPr>
+          <p:cNvPr id="2" name="Picture 1" descr="proc_belgium.png"/>
+          <p:cNvPicPr>
+            <a:picLocks noChangeAspect="1"/>
+          </p:cNvPicPr>
+          <p:nvPr/>
+        </p:nvPicPr>
+        <p:blipFill>
+          <a:blip r:embed="rId2"/>
+          <a:stretch>
+            <a:fillRect/>
+          </a:stretch>
+        </p:blipFill>
+        <p:spPr>
+          <a:xfrm>
+            <a:off x="0" y="0"/>
+            <a:ext cx="4320000" cy="2160000"/>
+          </a:xfrm>
+          <a:prstGeom prst="rect">
+            <a:avLst/>
+          </a:prstGeom>
+        </p:spPr>
+      </p:pic>
+    </p:spTree>
+  </p:cSld>
+  <p:clrMapOvr>
+    <a:masterClrMapping/>
+  </p:clrMapOvr>
+</p:sld>
+</file>
+
+<file path=ppt/slides/slide12.xml><?xml version="1.0" encoding="utf-8"?>
+<p:sld xmlns:a="http://schemas.openxmlformats.org/drawingml/2006/main" xmlns:p="http://schemas.openxmlformats.org/presentationml/2006/main" xmlns:r="http://schemas.openxmlformats.org/officeDocument/2006/relationships">
+  <p:cSld>
+    <p:spTree>
+      <p:nvGrpSpPr>
+        <p:cNvPr id="1" name=""/>
+        <p:cNvGrpSpPr/>
+        <p:nvPr/>
+      </p:nvGrpSpPr>
+      <p:grpSpPr/>
+      <p:pic>
+        <p:nvPicPr>
+          <p:cNvPr id="2" name="Picture 1" descr="proc_netherlands.png"/>
+          <p:cNvPicPr>
+            <a:picLocks noChangeAspect="1"/>
+          </p:cNvPicPr>
+          <p:nvPr/>
+        </p:nvPicPr>
+        <p:blipFill>
+          <a:blip r:embed="rId2"/>
+          <a:stretch>
+            <a:fillRect/>
+          </a:stretch>
+        </p:blipFill>
+        <p:spPr>
+          <a:xfrm>
+            <a:off x="0" y="0"/>
+            <a:ext cx="4320000" cy="2160000"/>
+          </a:xfrm>
+          <a:prstGeom prst="rect">
+            <a:avLst/>
+          </a:prstGeom>
+        </p:spPr>
+      </p:pic>
+    </p:spTree>
+  </p:cSld>
+  <p:clrMapOvr>
+    <a:masterClrMapping/>
+  </p:clrMapOvr>
+</p:sld>
+</file>
+
+<file path=ppt/slides/slide13.xml><?xml version="1.0" encoding="utf-8"?>
+<p:sld xmlns:a="http://schemas.openxmlformats.org/drawingml/2006/main" xmlns:p="http://schemas.openxmlformats.org/presentationml/2006/main" xmlns:r="http://schemas.openxmlformats.org/officeDocument/2006/relationships">
+  <p:cSld>
+    <p:spTree>
+      <p:nvGrpSpPr>
+        <p:cNvPr id="1" name=""/>
+        <p:cNvGrpSpPr/>
+        <p:nvPr/>
+      </p:nvGrpSpPr>
+      <p:grpSpPr/>
+      <p:pic>
+        <p:nvPicPr>
+          <p:cNvPr id="2" name="Picture 1" descr="proc_portugal.png"/>
+          <p:cNvPicPr>
+            <a:picLocks noChangeAspect="1"/>
+          </p:cNvPicPr>
+          <p:nvPr/>
+        </p:nvPicPr>
+        <p:blipFill>
+          <a:blip r:embed="rId2"/>
+          <a:stretch>
+            <a:fillRect/>
+          </a:stretch>
+        </p:blipFill>
+        <p:spPr>
+          <a:xfrm>
+            <a:off x="0" y="0"/>
+            <a:ext cx="4320000" cy="2160000"/>
+          </a:xfrm>
+          <a:prstGeom prst="rect">
+            <a:avLst/>
+          </a:prstGeom>
+        </p:spPr>
+      </p:pic>
+    </p:spTree>
+  </p:cSld>
+  <p:clrMapOvr>
+    <a:masterClrMapping/>
+  </p:clrMapOvr>
+</p:sld>
+</file>
+
+<file path=ppt/slides/slide14.xml><?xml version="1.0" encoding="utf-8"?>
+<p:sld xmlns:a="http://schemas.openxmlformats.org/drawingml/2006/main" xmlns:p="http://schemas.openxmlformats.org/presentationml/2006/main" xmlns:r="http://schemas.openxmlformats.org/officeDocument/2006/relationships">
+  <p:cSld>
+    <p:spTree>
+      <p:nvGrpSpPr>
+        <p:cNvPr id="1" name=""/>
+        <p:cNvGrpSpPr/>
+        <p:nvPr/>
+      </p:nvGrpSpPr>
+      <p:grpSpPr/>
+      <p:pic>
+        <p:nvPicPr>
+          <p:cNvPr id="2" name="Picture 1" descr="proc_spain.png"/>
+          <p:cNvPicPr>
+            <a:picLocks noChangeAspect="1"/>
+          </p:cNvPicPr>
+          <p:nvPr/>
+        </p:nvPicPr>
+        <p:blipFill>
+          <a:blip r:embed="rId2"/>
+          <a:stretch>
+            <a:fillRect/>
+          </a:stretch>
+        </p:blipFill>
+        <p:spPr>
+          <a:xfrm>
+            <a:off x="0" y="0"/>
+            <a:ext cx="4320000" cy="2160000"/>
+          </a:xfrm>
+          <a:prstGeom prst="rect">
+            <a:avLst/>
+          </a:prstGeom>
+        </p:spPr>
+      </p:pic>
+    </p:spTree>
+  </p:cSld>
+  <p:clrMapOvr>
+    <a:masterClrMapping/>
+  </p:clrMapOvr>
+</p:sld>
+</file>
+
+<file path=ppt/slides/slide15.xml><?xml version="1.0" encoding="utf-8"?>
+<p:sld xmlns:a="http://schemas.openxmlformats.org/drawingml/2006/main" xmlns:p="http://schemas.openxmlformats.org/presentationml/2006/main" xmlns:r="http://schemas.openxmlformats.org/officeDocument/2006/relationships">
+  <p:cSld>
+    <p:spTree>
+      <p:nvGrpSpPr>
+        <p:cNvPr id="1" name=""/>
+        <p:cNvGrpSpPr/>
+        <p:nvPr/>
+      </p:nvGrpSpPr>
+      <p:grpSpPr/>
+      <p:pic>
+        <p:nvPicPr>
+          <p:cNvPr id="2" name="Picture 1" descr="proc_germany.png"/>
           <p:cNvPicPr>
             <a:picLocks noChangeAspect="1"/>
           </p:cNvPicPr>

</xml_diff>

<commit_message>
Prints PPTX: add England, South Africa, Senegal, Egypt, Morocco (now 20)
Each 120x60mm; borders trimmed. Egypt/Senegal/Morocco (centered emblems) use
edge-stripe extension; England/South Africa fill edge-to-edge. Egypt now uses
the user-provided real image (Eagle of Saladin intact).

Co-Authored-By: Claude Opus 4.8 <noreply@anthropic.com>
Claude-Session: https://claude.ai/code/session_01TnVy1C21x68ctXsvvdvyLV
</commit_message>
<xml_diff>
--- a/print/C-Garden-Prints-120x60mm.pptx
+++ b/print/C-Garden-Prints-120x60mm.pptx
@@ -20,6 +20,11 @@
     <p:sldId id="268" r:id="rId19"/>
     <p:sldId id="269" r:id="rId20"/>
     <p:sldId id="270" r:id="rId21"/>
+    <p:sldId id="271" r:id="rId22"/>
+    <p:sldId id="272" r:id="rId23"/>
+    <p:sldId id="273" r:id="rId24"/>
+    <p:sldId id="274" r:id="rId25"/>
+    <p:sldId id="275" r:id="rId26"/>
   </p:sldIdLst>
   <p:sldSz cx="4320000" cy="2160000" type="screen4x3"/>
   <p:notesSz cx="6858000" cy="9144000"/>
@@ -3386,6 +3391,174 @@
 </p:sld>
 </file>
 
+<file path=ppt/slides/slide16.xml><?xml version="1.0" encoding="utf-8"?>
+<p:sld xmlns:a="http://schemas.openxmlformats.org/drawingml/2006/main" xmlns:p="http://schemas.openxmlformats.org/presentationml/2006/main" xmlns:r="http://schemas.openxmlformats.org/officeDocument/2006/relationships">
+  <p:cSld>
+    <p:spTree>
+      <p:nvGrpSpPr>
+        <p:cNvPr id="1" name=""/>
+        <p:cNvGrpSpPr/>
+        <p:nvPr/>
+      </p:nvGrpSpPr>
+      <p:grpSpPr/>
+      <p:pic>
+        <p:nvPicPr>
+          <p:cNvPr id="2" name="Picture 1" descr="proc_england.png"/>
+          <p:cNvPicPr>
+            <a:picLocks noChangeAspect="1"/>
+          </p:cNvPicPr>
+          <p:nvPr/>
+        </p:nvPicPr>
+        <p:blipFill>
+          <a:blip r:embed="rId2"/>
+          <a:stretch>
+            <a:fillRect/>
+          </a:stretch>
+        </p:blipFill>
+        <p:spPr>
+          <a:xfrm>
+            <a:off x="0" y="0"/>
+            <a:ext cx="4320000" cy="2160000"/>
+          </a:xfrm>
+          <a:prstGeom prst="rect">
+            <a:avLst/>
+          </a:prstGeom>
+        </p:spPr>
+      </p:pic>
+    </p:spTree>
+  </p:cSld>
+  <p:clrMapOvr>
+    <a:masterClrMapping/>
+  </p:clrMapOvr>
+</p:sld>
+</file>
+
+<file path=ppt/slides/slide17.xml><?xml version="1.0" encoding="utf-8"?>
+<p:sld xmlns:a="http://schemas.openxmlformats.org/drawingml/2006/main" xmlns:p="http://schemas.openxmlformats.org/presentationml/2006/main" xmlns:r="http://schemas.openxmlformats.org/officeDocument/2006/relationships">
+  <p:cSld>
+    <p:spTree>
+      <p:nvGrpSpPr>
+        <p:cNvPr id="1" name=""/>
+        <p:cNvGrpSpPr/>
+        <p:nvPr/>
+      </p:nvGrpSpPr>
+      <p:grpSpPr/>
+      <p:pic>
+        <p:nvPicPr>
+          <p:cNvPr id="2" name="Picture 1" descr="proc_southafrica.png"/>
+          <p:cNvPicPr>
+            <a:picLocks noChangeAspect="1"/>
+          </p:cNvPicPr>
+          <p:nvPr/>
+        </p:nvPicPr>
+        <p:blipFill>
+          <a:blip r:embed="rId2"/>
+          <a:stretch>
+            <a:fillRect/>
+          </a:stretch>
+        </p:blipFill>
+        <p:spPr>
+          <a:xfrm>
+            <a:off x="0" y="0"/>
+            <a:ext cx="4320000" cy="2160000"/>
+          </a:xfrm>
+          <a:prstGeom prst="rect">
+            <a:avLst/>
+          </a:prstGeom>
+        </p:spPr>
+      </p:pic>
+    </p:spTree>
+  </p:cSld>
+  <p:clrMapOvr>
+    <a:masterClrMapping/>
+  </p:clrMapOvr>
+</p:sld>
+</file>
+
+<file path=ppt/slides/slide18.xml><?xml version="1.0" encoding="utf-8"?>
+<p:sld xmlns:a="http://schemas.openxmlformats.org/drawingml/2006/main" xmlns:p="http://schemas.openxmlformats.org/presentationml/2006/main" xmlns:r="http://schemas.openxmlformats.org/officeDocument/2006/relationships">
+  <p:cSld>
+    <p:spTree>
+      <p:nvGrpSpPr>
+        <p:cNvPr id="1" name=""/>
+        <p:cNvGrpSpPr/>
+        <p:nvPr/>
+      </p:nvGrpSpPr>
+      <p:grpSpPr/>
+      <p:pic>
+        <p:nvPicPr>
+          <p:cNvPr id="2" name="Picture 1" descr="proc_senegal.png"/>
+          <p:cNvPicPr>
+            <a:picLocks noChangeAspect="1"/>
+          </p:cNvPicPr>
+          <p:nvPr/>
+        </p:nvPicPr>
+        <p:blipFill>
+          <a:blip r:embed="rId2"/>
+          <a:stretch>
+            <a:fillRect/>
+          </a:stretch>
+        </p:blipFill>
+        <p:spPr>
+          <a:xfrm>
+            <a:off x="0" y="0"/>
+            <a:ext cx="4320000" cy="2160000"/>
+          </a:xfrm>
+          <a:prstGeom prst="rect">
+            <a:avLst/>
+          </a:prstGeom>
+        </p:spPr>
+      </p:pic>
+    </p:spTree>
+  </p:cSld>
+  <p:clrMapOvr>
+    <a:masterClrMapping/>
+  </p:clrMapOvr>
+</p:sld>
+</file>
+
+<file path=ppt/slides/slide19.xml><?xml version="1.0" encoding="utf-8"?>
+<p:sld xmlns:a="http://schemas.openxmlformats.org/drawingml/2006/main" xmlns:p="http://schemas.openxmlformats.org/presentationml/2006/main" xmlns:r="http://schemas.openxmlformats.org/officeDocument/2006/relationships">
+  <p:cSld>
+    <p:spTree>
+      <p:nvGrpSpPr>
+        <p:cNvPr id="1" name=""/>
+        <p:cNvGrpSpPr/>
+        <p:nvPr/>
+      </p:nvGrpSpPr>
+      <p:grpSpPr/>
+      <p:pic>
+        <p:nvPicPr>
+          <p:cNvPr id="2" name="Picture 1" descr="proc_egypt.png"/>
+          <p:cNvPicPr>
+            <a:picLocks noChangeAspect="1"/>
+          </p:cNvPicPr>
+          <p:nvPr/>
+        </p:nvPicPr>
+        <p:blipFill>
+          <a:blip r:embed="rId2"/>
+          <a:stretch>
+            <a:fillRect/>
+          </a:stretch>
+        </p:blipFill>
+        <p:spPr>
+          <a:xfrm>
+            <a:off x="0" y="0"/>
+            <a:ext cx="4320000" cy="2160000"/>
+          </a:xfrm>
+          <a:prstGeom prst="rect">
+            <a:avLst/>
+          </a:prstGeom>
+        </p:spPr>
+      </p:pic>
+    </p:spTree>
+  </p:cSld>
+  <p:clrMapOvr>
+    <a:masterClrMapping/>
+  </p:clrMapOvr>
+</p:sld>
+</file>
+
 <file path=ppt/slides/slide2.xml><?xml version="1.0" encoding="utf-8"?>
 <p:sld xmlns:a="http://schemas.openxmlformats.org/drawingml/2006/main" xmlns:p="http://schemas.openxmlformats.org/presentationml/2006/main" xmlns:r="http://schemas.openxmlformats.org/officeDocument/2006/relationships">
   <p:cSld>
@@ -3399,6 +3572,48 @@
       <p:pic>
         <p:nvPicPr>
           <p:cNvPr id="2" name="Picture 1" descr="proc_emblem.png"/>
+          <p:cNvPicPr>
+            <a:picLocks noChangeAspect="1"/>
+          </p:cNvPicPr>
+          <p:nvPr/>
+        </p:nvPicPr>
+        <p:blipFill>
+          <a:blip r:embed="rId2"/>
+          <a:stretch>
+            <a:fillRect/>
+          </a:stretch>
+        </p:blipFill>
+        <p:spPr>
+          <a:xfrm>
+            <a:off x="0" y="0"/>
+            <a:ext cx="4320000" cy="2160000"/>
+          </a:xfrm>
+          <a:prstGeom prst="rect">
+            <a:avLst/>
+          </a:prstGeom>
+        </p:spPr>
+      </p:pic>
+    </p:spTree>
+  </p:cSld>
+  <p:clrMapOvr>
+    <a:masterClrMapping/>
+  </p:clrMapOvr>
+</p:sld>
+</file>
+
+<file path=ppt/slides/slide20.xml><?xml version="1.0" encoding="utf-8"?>
+<p:sld xmlns:a="http://schemas.openxmlformats.org/drawingml/2006/main" xmlns:p="http://schemas.openxmlformats.org/presentationml/2006/main" xmlns:r="http://schemas.openxmlformats.org/officeDocument/2006/relationships">
+  <p:cSld>
+    <p:spTree>
+      <p:nvGrpSpPr>
+        <p:cNvPr id="1" name=""/>
+        <p:cNvGrpSpPr/>
+        <p:nvPr/>
+      </p:nvGrpSpPr>
+      <p:grpSpPr/>
+      <p:pic>
+        <p:nvPicPr>
+          <p:cNvPr id="2" name="Picture 1" descr="proc_morocco.png"/>
           <p:cNvPicPr>
             <a:picLocks noChangeAspect="1"/>
           </p:cNvPicPr>

</xml_diff>

<commit_message>
Prints PPTX: add Jordan, Iran, South Korea, Japan, Australia (now 25)
Each 120x60mm; borders trimmed. South Korea (corner trigrams) uses edge
extension; others fill edge-to-edge.

Co-Authored-By: Claude Opus 4.8 <noreply@anthropic.com>
Claude-Session: https://claude.ai/code/session_01TnVy1C21x68ctXsvvdvyLV
</commit_message>
<xml_diff>
--- a/print/C-Garden-Prints-120x60mm.pptx
+++ b/print/C-Garden-Prints-120x60mm.pptx
@@ -25,6 +25,11 @@
     <p:sldId id="273" r:id="rId24"/>
     <p:sldId id="274" r:id="rId25"/>
     <p:sldId id="275" r:id="rId26"/>
+    <p:sldId id="276" r:id="rId27"/>
+    <p:sldId id="277" r:id="rId28"/>
+    <p:sldId id="278" r:id="rId29"/>
+    <p:sldId id="279" r:id="rId30"/>
+    <p:sldId id="280" r:id="rId31"/>
   </p:sldIdLst>
   <p:sldSz cx="4320000" cy="2160000" type="screen4x3"/>
   <p:notesSz cx="6858000" cy="9144000"/>
@@ -3614,6 +3619,216 @@
       <p:pic>
         <p:nvPicPr>
           <p:cNvPr id="2" name="Picture 1" descr="proc_morocco.png"/>
+          <p:cNvPicPr>
+            <a:picLocks noChangeAspect="1"/>
+          </p:cNvPicPr>
+          <p:nvPr/>
+        </p:nvPicPr>
+        <p:blipFill>
+          <a:blip r:embed="rId2"/>
+          <a:stretch>
+            <a:fillRect/>
+          </a:stretch>
+        </p:blipFill>
+        <p:spPr>
+          <a:xfrm>
+            <a:off x="0" y="0"/>
+            <a:ext cx="4320000" cy="2160000"/>
+          </a:xfrm>
+          <a:prstGeom prst="rect">
+            <a:avLst/>
+          </a:prstGeom>
+        </p:spPr>
+      </p:pic>
+    </p:spTree>
+  </p:cSld>
+  <p:clrMapOvr>
+    <a:masterClrMapping/>
+  </p:clrMapOvr>
+</p:sld>
+</file>
+
+<file path=ppt/slides/slide21.xml><?xml version="1.0" encoding="utf-8"?>
+<p:sld xmlns:a="http://schemas.openxmlformats.org/drawingml/2006/main" xmlns:p="http://schemas.openxmlformats.org/presentationml/2006/main" xmlns:r="http://schemas.openxmlformats.org/officeDocument/2006/relationships">
+  <p:cSld>
+    <p:spTree>
+      <p:nvGrpSpPr>
+        <p:cNvPr id="1" name=""/>
+        <p:cNvGrpSpPr/>
+        <p:nvPr/>
+      </p:nvGrpSpPr>
+      <p:grpSpPr/>
+      <p:pic>
+        <p:nvPicPr>
+          <p:cNvPr id="2" name="Picture 1" descr="proc_jordan.png"/>
+          <p:cNvPicPr>
+            <a:picLocks noChangeAspect="1"/>
+          </p:cNvPicPr>
+          <p:nvPr/>
+        </p:nvPicPr>
+        <p:blipFill>
+          <a:blip r:embed="rId2"/>
+          <a:stretch>
+            <a:fillRect/>
+          </a:stretch>
+        </p:blipFill>
+        <p:spPr>
+          <a:xfrm>
+            <a:off x="0" y="0"/>
+            <a:ext cx="4320000" cy="2160000"/>
+          </a:xfrm>
+          <a:prstGeom prst="rect">
+            <a:avLst/>
+          </a:prstGeom>
+        </p:spPr>
+      </p:pic>
+    </p:spTree>
+  </p:cSld>
+  <p:clrMapOvr>
+    <a:masterClrMapping/>
+  </p:clrMapOvr>
+</p:sld>
+</file>
+
+<file path=ppt/slides/slide22.xml><?xml version="1.0" encoding="utf-8"?>
+<p:sld xmlns:a="http://schemas.openxmlformats.org/drawingml/2006/main" xmlns:p="http://schemas.openxmlformats.org/presentationml/2006/main" xmlns:r="http://schemas.openxmlformats.org/officeDocument/2006/relationships">
+  <p:cSld>
+    <p:spTree>
+      <p:nvGrpSpPr>
+        <p:cNvPr id="1" name=""/>
+        <p:cNvGrpSpPr/>
+        <p:nvPr/>
+      </p:nvGrpSpPr>
+      <p:grpSpPr/>
+      <p:pic>
+        <p:nvPicPr>
+          <p:cNvPr id="2" name="Picture 1" descr="proc_iran.png"/>
+          <p:cNvPicPr>
+            <a:picLocks noChangeAspect="1"/>
+          </p:cNvPicPr>
+          <p:nvPr/>
+        </p:nvPicPr>
+        <p:blipFill>
+          <a:blip r:embed="rId2"/>
+          <a:stretch>
+            <a:fillRect/>
+          </a:stretch>
+        </p:blipFill>
+        <p:spPr>
+          <a:xfrm>
+            <a:off x="0" y="0"/>
+            <a:ext cx="4320000" cy="2160000"/>
+          </a:xfrm>
+          <a:prstGeom prst="rect">
+            <a:avLst/>
+          </a:prstGeom>
+        </p:spPr>
+      </p:pic>
+    </p:spTree>
+  </p:cSld>
+  <p:clrMapOvr>
+    <a:masterClrMapping/>
+  </p:clrMapOvr>
+</p:sld>
+</file>
+
+<file path=ppt/slides/slide23.xml><?xml version="1.0" encoding="utf-8"?>
+<p:sld xmlns:a="http://schemas.openxmlformats.org/drawingml/2006/main" xmlns:p="http://schemas.openxmlformats.org/presentationml/2006/main" xmlns:r="http://schemas.openxmlformats.org/officeDocument/2006/relationships">
+  <p:cSld>
+    <p:spTree>
+      <p:nvGrpSpPr>
+        <p:cNvPr id="1" name=""/>
+        <p:cNvGrpSpPr/>
+        <p:nvPr/>
+      </p:nvGrpSpPr>
+      <p:grpSpPr/>
+      <p:pic>
+        <p:nvPicPr>
+          <p:cNvPr id="2" name="Picture 1" descr="proc_southkorea.png"/>
+          <p:cNvPicPr>
+            <a:picLocks noChangeAspect="1"/>
+          </p:cNvPicPr>
+          <p:nvPr/>
+        </p:nvPicPr>
+        <p:blipFill>
+          <a:blip r:embed="rId2"/>
+          <a:stretch>
+            <a:fillRect/>
+          </a:stretch>
+        </p:blipFill>
+        <p:spPr>
+          <a:xfrm>
+            <a:off x="0" y="0"/>
+            <a:ext cx="4320000" cy="2160000"/>
+          </a:xfrm>
+          <a:prstGeom prst="rect">
+            <a:avLst/>
+          </a:prstGeom>
+        </p:spPr>
+      </p:pic>
+    </p:spTree>
+  </p:cSld>
+  <p:clrMapOvr>
+    <a:masterClrMapping/>
+  </p:clrMapOvr>
+</p:sld>
+</file>
+
+<file path=ppt/slides/slide24.xml><?xml version="1.0" encoding="utf-8"?>
+<p:sld xmlns:a="http://schemas.openxmlformats.org/drawingml/2006/main" xmlns:p="http://schemas.openxmlformats.org/presentationml/2006/main" xmlns:r="http://schemas.openxmlformats.org/officeDocument/2006/relationships">
+  <p:cSld>
+    <p:spTree>
+      <p:nvGrpSpPr>
+        <p:cNvPr id="1" name=""/>
+        <p:cNvGrpSpPr/>
+        <p:nvPr/>
+      </p:nvGrpSpPr>
+      <p:grpSpPr/>
+      <p:pic>
+        <p:nvPicPr>
+          <p:cNvPr id="2" name="Picture 1" descr="proc_japan.png"/>
+          <p:cNvPicPr>
+            <a:picLocks noChangeAspect="1"/>
+          </p:cNvPicPr>
+          <p:nvPr/>
+        </p:nvPicPr>
+        <p:blipFill>
+          <a:blip r:embed="rId2"/>
+          <a:stretch>
+            <a:fillRect/>
+          </a:stretch>
+        </p:blipFill>
+        <p:spPr>
+          <a:xfrm>
+            <a:off x="0" y="0"/>
+            <a:ext cx="4320000" cy="2160000"/>
+          </a:xfrm>
+          <a:prstGeom prst="rect">
+            <a:avLst/>
+          </a:prstGeom>
+        </p:spPr>
+      </p:pic>
+    </p:spTree>
+  </p:cSld>
+  <p:clrMapOvr>
+    <a:masterClrMapping/>
+  </p:clrMapOvr>
+</p:sld>
+</file>
+
+<file path=ppt/slides/slide25.xml><?xml version="1.0" encoding="utf-8"?>
+<p:sld xmlns:a="http://schemas.openxmlformats.org/drawingml/2006/main" xmlns:p="http://schemas.openxmlformats.org/presentationml/2006/main" xmlns:r="http://schemas.openxmlformats.org/officeDocument/2006/relationships">
+  <p:cSld>
+    <p:spTree>
+      <p:nvGrpSpPr>
+        <p:cNvPr id="1" name=""/>
+        <p:cNvGrpSpPr/>
+        <p:nvPr/>
+      </p:nvGrpSpPr>
+      <p:grpSpPr/>
+      <p:pic>
+        <p:nvPicPr>
+          <p:cNvPr id="2" name="Picture 1" descr="proc_australia.png"/>
           <p:cNvPicPr>
             <a:picLocks noChangeAspect="1"/>
           </p:cNvPicPr>

</xml_diff>

<commit_message>
Prints PPTX: add USA, Ecuador, Brazil, Mexico, Canada (now 30)
Each 120x60mm; borders trimmed. Ecuador/Brazil (large centered emblems) use
edge-stripe extension; others fill edge-to-edge.

Co-Authored-By: Claude Opus 4.8 <noreply@anthropic.com>
Claude-Session: https://claude.ai/code/session_01TnVy1C21x68ctXsvvdvyLV
</commit_message>
<xml_diff>
--- a/print/C-Garden-Prints-120x60mm.pptx
+++ b/print/C-Garden-Prints-120x60mm.pptx
@@ -30,6 +30,11 @@
     <p:sldId id="278" r:id="rId29"/>
     <p:sldId id="279" r:id="rId30"/>
     <p:sldId id="280" r:id="rId31"/>
+    <p:sldId id="281" r:id="rId32"/>
+    <p:sldId id="282" r:id="rId33"/>
+    <p:sldId id="283" r:id="rId34"/>
+    <p:sldId id="284" r:id="rId35"/>
+    <p:sldId id="285" r:id="rId36"/>
   </p:sldIdLst>
   <p:sldSz cx="4320000" cy="2160000" type="screen4x3"/>
   <p:notesSz cx="6858000" cy="9144000"/>
@@ -3858,6 +3863,174 @@
 </p:sld>
 </file>
 
+<file path=ppt/slides/slide26.xml><?xml version="1.0" encoding="utf-8"?>
+<p:sld xmlns:a="http://schemas.openxmlformats.org/drawingml/2006/main" xmlns:p="http://schemas.openxmlformats.org/presentationml/2006/main" xmlns:r="http://schemas.openxmlformats.org/officeDocument/2006/relationships">
+  <p:cSld>
+    <p:spTree>
+      <p:nvGrpSpPr>
+        <p:cNvPr id="1" name=""/>
+        <p:cNvGrpSpPr/>
+        <p:nvPr/>
+      </p:nvGrpSpPr>
+      <p:grpSpPr/>
+      <p:pic>
+        <p:nvPicPr>
+          <p:cNvPr id="2" name="Picture 1" descr="proc_usa.png"/>
+          <p:cNvPicPr>
+            <a:picLocks noChangeAspect="1"/>
+          </p:cNvPicPr>
+          <p:nvPr/>
+        </p:nvPicPr>
+        <p:blipFill>
+          <a:blip r:embed="rId2"/>
+          <a:stretch>
+            <a:fillRect/>
+          </a:stretch>
+        </p:blipFill>
+        <p:spPr>
+          <a:xfrm>
+            <a:off x="0" y="0"/>
+            <a:ext cx="4320000" cy="2160000"/>
+          </a:xfrm>
+          <a:prstGeom prst="rect">
+            <a:avLst/>
+          </a:prstGeom>
+        </p:spPr>
+      </p:pic>
+    </p:spTree>
+  </p:cSld>
+  <p:clrMapOvr>
+    <a:masterClrMapping/>
+  </p:clrMapOvr>
+</p:sld>
+</file>
+
+<file path=ppt/slides/slide27.xml><?xml version="1.0" encoding="utf-8"?>
+<p:sld xmlns:a="http://schemas.openxmlformats.org/drawingml/2006/main" xmlns:p="http://schemas.openxmlformats.org/presentationml/2006/main" xmlns:r="http://schemas.openxmlformats.org/officeDocument/2006/relationships">
+  <p:cSld>
+    <p:spTree>
+      <p:nvGrpSpPr>
+        <p:cNvPr id="1" name=""/>
+        <p:cNvGrpSpPr/>
+        <p:nvPr/>
+      </p:nvGrpSpPr>
+      <p:grpSpPr/>
+      <p:pic>
+        <p:nvPicPr>
+          <p:cNvPr id="2" name="Picture 1" descr="proc_ecuador.png"/>
+          <p:cNvPicPr>
+            <a:picLocks noChangeAspect="1"/>
+          </p:cNvPicPr>
+          <p:nvPr/>
+        </p:nvPicPr>
+        <p:blipFill>
+          <a:blip r:embed="rId2"/>
+          <a:stretch>
+            <a:fillRect/>
+          </a:stretch>
+        </p:blipFill>
+        <p:spPr>
+          <a:xfrm>
+            <a:off x="0" y="0"/>
+            <a:ext cx="4320000" cy="2160000"/>
+          </a:xfrm>
+          <a:prstGeom prst="rect">
+            <a:avLst/>
+          </a:prstGeom>
+        </p:spPr>
+      </p:pic>
+    </p:spTree>
+  </p:cSld>
+  <p:clrMapOvr>
+    <a:masterClrMapping/>
+  </p:clrMapOvr>
+</p:sld>
+</file>
+
+<file path=ppt/slides/slide28.xml><?xml version="1.0" encoding="utf-8"?>
+<p:sld xmlns:a="http://schemas.openxmlformats.org/drawingml/2006/main" xmlns:p="http://schemas.openxmlformats.org/presentationml/2006/main" xmlns:r="http://schemas.openxmlformats.org/officeDocument/2006/relationships">
+  <p:cSld>
+    <p:spTree>
+      <p:nvGrpSpPr>
+        <p:cNvPr id="1" name=""/>
+        <p:cNvGrpSpPr/>
+        <p:nvPr/>
+      </p:nvGrpSpPr>
+      <p:grpSpPr/>
+      <p:pic>
+        <p:nvPicPr>
+          <p:cNvPr id="2" name="Picture 1" descr="proc_brazil.png"/>
+          <p:cNvPicPr>
+            <a:picLocks noChangeAspect="1"/>
+          </p:cNvPicPr>
+          <p:nvPr/>
+        </p:nvPicPr>
+        <p:blipFill>
+          <a:blip r:embed="rId2"/>
+          <a:stretch>
+            <a:fillRect/>
+          </a:stretch>
+        </p:blipFill>
+        <p:spPr>
+          <a:xfrm>
+            <a:off x="0" y="0"/>
+            <a:ext cx="4320000" cy="2160000"/>
+          </a:xfrm>
+          <a:prstGeom prst="rect">
+            <a:avLst/>
+          </a:prstGeom>
+        </p:spPr>
+      </p:pic>
+    </p:spTree>
+  </p:cSld>
+  <p:clrMapOvr>
+    <a:masterClrMapping/>
+  </p:clrMapOvr>
+</p:sld>
+</file>
+
+<file path=ppt/slides/slide29.xml><?xml version="1.0" encoding="utf-8"?>
+<p:sld xmlns:a="http://schemas.openxmlformats.org/drawingml/2006/main" xmlns:p="http://schemas.openxmlformats.org/presentationml/2006/main" xmlns:r="http://schemas.openxmlformats.org/officeDocument/2006/relationships">
+  <p:cSld>
+    <p:spTree>
+      <p:nvGrpSpPr>
+        <p:cNvPr id="1" name=""/>
+        <p:cNvGrpSpPr/>
+        <p:nvPr/>
+      </p:nvGrpSpPr>
+      <p:grpSpPr/>
+      <p:pic>
+        <p:nvPicPr>
+          <p:cNvPr id="2" name="Picture 1" descr="proc_mexico.png"/>
+          <p:cNvPicPr>
+            <a:picLocks noChangeAspect="1"/>
+          </p:cNvPicPr>
+          <p:nvPr/>
+        </p:nvPicPr>
+        <p:blipFill>
+          <a:blip r:embed="rId2"/>
+          <a:stretch>
+            <a:fillRect/>
+          </a:stretch>
+        </p:blipFill>
+        <p:spPr>
+          <a:xfrm>
+            <a:off x="0" y="0"/>
+            <a:ext cx="4320000" cy="2160000"/>
+          </a:xfrm>
+          <a:prstGeom prst="rect">
+            <a:avLst/>
+          </a:prstGeom>
+        </p:spPr>
+      </p:pic>
+    </p:spTree>
+  </p:cSld>
+  <p:clrMapOvr>
+    <a:masterClrMapping/>
+  </p:clrMapOvr>
+</p:sld>
+</file>
+
 <file path=ppt/slides/slide3.xml><?xml version="1.0" encoding="utf-8"?>
 <p:sld xmlns:a="http://schemas.openxmlformats.org/drawingml/2006/main" xmlns:p="http://schemas.openxmlformats.org/presentationml/2006/main" xmlns:r="http://schemas.openxmlformats.org/officeDocument/2006/relationships">
   <p:cSld>
@@ -3871,6 +4044,48 @@
       <p:pic>
         <p:nvPicPr>
           <p:cNvPr id="2" name="Picture 1" descr="proc_mongolia.png"/>
+          <p:cNvPicPr>
+            <a:picLocks noChangeAspect="1"/>
+          </p:cNvPicPr>
+          <p:nvPr/>
+        </p:nvPicPr>
+        <p:blipFill>
+          <a:blip r:embed="rId2"/>
+          <a:stretch>
+            <a:fillRect/>
+          </a:stretch>
+        </p:blipFill>
+        <p:spPr>
+          <a:xfrm>
+            <a:off x="0" y="0"/>
+            <a:ext cx="4320000" cy="2160000"/>
+          </a:xfrm>
+          <a:prstGeom prst="rect">
+            <a:avLst/>
+          </a:prstGeom>
+        </p:spPr>
+      </p:pic>
+    </p:spTree>
+  </p:cSld>
+  <p:clrMapOvr>
+    <a:masterClrMapping/>
+  </p:clrMapOvr>
+</p:sld>
+</file>
+
+<file path=ppt/slides/slide30.xml><?xml version="1.0" encoding="utf-8"?>
+<p:sld xmlns:a="http://schemas.openxmlformats.org/drawingml/2006/main" xmlns:p="http://schemas.openxmlformats.org/presentationml/2006/main" xmlns:r="http://schemas.openxmlformats.org/officeDocument/2006/relationships">
+  <p:cSld>
+    <p:spTree>
+      <p:nvGrpSpPr>
+        <p:cNvPr id="1" name=""/>
+        <p:cNvGrpSpPr/>
+        <p:nvPr/>
+      </p:nvGrpSpPr>
+      <p:grpSpPr/>
+      <p:pic>
+        <p:nvPicPr>
+          <p:cNvPr id="2" name="Picture 1" descr="proc_canada.png"/>
           <p:cNvPicPr>
             <a:picLocks noChangeAspect="1"/>
           </p:cNvPicPr>

</xml_diff>

<commit_message>
Prints PPTX: add Norway, Croatia, France, Uzbekistan, Argentina (now 35)
Each 120x60mm; borders trimmed. Croatia (crown of shields) and Uzbekistan
(crescent+stars canton) use edge extension; others fill edge-to-edge.

Co-Authored-By: Claude Opus 4.8 <noreply@anthropic.com>
Claude-Session: https://claude.ai/code/session_01TnVy1C21x68ctXsvvdvyLV
</commit_message>
<xml_diff>
--- a/print/C-Garden-Prints-120x60mm.pptx
+++ b/print/C-Garden-Prints-120x60mm.pptx
@@ -35,6 +35,11 @@
     <p:sldId id="283" r:id="rId34"/>
     <p:sldId id="284" r:id="rId35"/>
     <p:sldId id="285" r:id="rId36"/>
+    <p:sldId id="286" r:id="rId37"/>
+    <p:sldId id="287" r:id="rId38"/>
+    <p:sldId id="288" r:id="rId39"/>
+    <p:sldId id="289" r:id="rId40"/>
+    <p:sldId id="290" r:id="rId41"/>
   </p:sldIdLst>
   <p:sldSz cx="4320000" cy="2160000" type="screen4x3"/>
   <p:notesSz cx="6858000" cy="9144000"/>
@@ -4086,6 +4091,216 @@
       <p:pic>
         <p:nvPicPr>
           <p:cNvPr id="2" name="Picture 1" descr="proc_canada.png"/>
+          <p:cNvPicPr>
+            <a:picLocks noChangeAspect="1"/>
+          </p:cNvPicPr>
+          <p:nvPr/>
+        </p:nvPicPr>
+        <p:blipFill>
+          <a:blip r:embed="rId2"/>
+          <a:stretch>
+            <a:fillRect/>
+          </a:stretch>
+        </p:blipFill>
+        <p:spPr>
+          <a:xfrm>
+            <a:off x="0" y="0"/>
+            <a:ext cx="4320000" cy="2160000"/>
+          </a:xfrm>
+          <a:prstGeom prst="rect">
+            <a:avLst/>
+          </a:prstGeom>
+        </p:spPr>
+      </p:pic>
+    </p:spTree>
+  </p:cSld>
+  <p:clrMapOvr>
+    <a:masterClrMapping/>
+  </p:clrMapOvr>
+</p:sld>
+</file>
+
+<file path=ppt/slides/slide31.xml><?xml version="1.0" encoding="utf-8"?>
+<p:sld xmlns:a="http://schemas.openxmlformats.org/drawingml/2006/main" xmlns:p="http://schemas.openxmlformats.org/presentationml/2006/main" xmlns:r="http://schemas.openxmlformats.org/officeDocument/2006/relationships">
+  <p:cSld>
+    <p:spTree>
+      <p:nvGrpSpPr>
+        <p:cNvPr id="1" name=""/>
+        <p:cNvGrpSpPr/>
+        <p:nvPr/>
+      </p:nvGrpSpPr>
+      <p:grpSpPr/>
+      <p:pic>
+        <p:nvPicPr>
+          <p:cNvPr id="2" name="Picture 1" descr="proc_norway.png"/>
+          <p:cNvPicPr>
+            <a:picLocks noChangeAspect="1"/>
+          </p:cNvPicPr>
+          <p:nvPr/>
+        </p:nvPicPr>
+        <p:blipFill>
+          <a:blip r:embed="rId2"/>
+          <a:stretch>
+            <a:fillRect/>
+          </a:stretch>
+        </p:blipFill>
+        <p:spPr>
+          <a:xfrm>
+            <a:off x="0" y="0"/>
+            <a:ext cx="4320000" cy="2160000"/>
+          </a:xfrm>
+          <a:prstGeom prst="rect">
+            <a:avLst/>
+          </a:prstGeom>
+        </p:spPr>
+      </p:pic>
+    </p:spTree>
+  </p:cSld>
+  <p:clrMapOvr>
+    <a:masterClrMapping/>
+  </p:clrMapOvr>
+</p:sld>
+</file>
+
+<file path=ppt/slides/slide32.xml><?xml version="1.0" encoding="utf-8"?>
+<p:sld xmlns:a="http://schemas.openxmlformats.org/drawingml/2006/main" xmlns:p="http://schemas.openxmlformats.org/presentationml/2006/main" xmlns:r="http://schemas.openxmlformats.org/officeDocument/2006/relationships">
+  <p:cSld>
+    <p:spTree>
+      <p:nvGrpSpPr>
+        <p:cNvPr id="1" name=""/>
+        <p:cNvGrpSpPr/>
+        <p:nvPr/>
+      </p:nvGrpSpPr>
+      <p:grpSpPr/>
+      <p:pic>
+        <p:nvPicPr>
+          <p:cNvPr id="2" name="Picture 1" descr="proc_croatia.png"/>
+          <p:cNvPicPr>
+            <a:picLocks noChangeAspect="1"/>
+          </p:cNvPicPr>
+          <p:nvPr/>
+        </p:nvPicPr>
+        <p:blipFill>
+          <a:blip r:embed="rId2"/>
+          <a:stretch>
+            <a:fillRect/>
+          </a:stretch>
+        </p:blipFill>
+        <p:spPr>
+          <a:xfrm>
+            <a:off x="0" y="0"/>
+            <a:ext cx="4320000" cy="2160000"/>
+          </a:xfrm>
+          <a:prstGeom prst="rect">
+            <a:avLst/>
+          </a:prstGeom>
+        </p:spPr>
+      </p:pic>
+    </p:spTree>
+  </p:cSld>
+  <p:clrMapOvr>
+    <a:masterClrMapping/>
+  </p:clrMapOvr>
+</p:sld>
+</file>
+
+<file path=ppt/slides/slide33.xml><?xml version="1.0" encoding="utf-8"?>
+<p:sld xmlns:a="http://schemas.openxmlformats.org/drawingml/2006/main" xmlns:p="http://schemas.openxmlformats.org/presentationml/2006/main" xmlns:r="http://schemas.openxmlformats.org/officeDocument/2006/relationships">
+  <p:cSld>
+    <p:spTree>
+      <p:nvGrpSpPr>
+        <p:cNvPr id="1" name=""/>
+        <p:cNvGrpSpPr/>
+        <p:nvPr/>
+      </p:nvGrpSpPr>
+      <p:grpSpPr/>
+      <p:pic>
+        <p:nvPicPr>
+          <p:cNvPr id="2" name="Picture 1" descr="proc_france.png"/>
+          <p:cNvPicPr>
+            <a:picLocks noChangeAspect="1"/>
+          </p:cNvPicPr>
+          <p:nvPr/>
+        </p:nvPicPr>
+        <p:blipFill>
+          <a:blip r:embed="rId2"/>
+          <a:stretch>
+            <a:fillRect/>
+          </a:stretch>
+        </p:blipFill>
+        <p:spPr>
+          <a:xfrm>
+            <a:off x="0" y="0"/>
+            <a:ext cx="4320000" cy="2160000"/>
+          </a:xfrm>
+          <a:prstGeom prst="rect">
+            <a:avLst/>
+          </a:prstGeom>
+        </p:spPr>
+      </p:pic>
+    </p:spTree>
+  </p:cSld>
+  <p:clrMapOvr>
+    <a:masterClrMapping/>
+  </p:clrMapOvr>
+</p:sld>
+</file>
+
+<file path=ppt/slides/slide34.xml><?xml version="1.0" encoding="utf-8"?>
+<p:sld xmlns:a="http://schemas.openxmlformats.org/drawingml/2006/main" xmlns:p="http://schemas.openxmlformats.org/presentationml/2006/main" xmlns:r="http://schemas.openxmlformats.org/officeDocument/2006/relationships">
+  <p:cSld>
+    <p:spTree>
+      <p:nvGrpSpPr>
+        <p:cNvPr id="1" name=""/>
+        <p:cNvGrpSpPr/>
+        <p:nvPr/>
+      </p:nvGrpSpPr>
+      <p:grpSpPr/>
+      <p:pic>
+        <p:nvPicPr>
+          <p:cNvPr id="2" name="Picture 1" descr="proc_uzbekistan.png"/>
+          <p:cNvPicPr>
+            <a:picLocks noChangeAspect="1"/>
+          </p:cNvPicPr>
+          <p:nvPr/>
+        </p:nvPicPr>
+        <p:blipFill>
+          <a:blip r:embed="rId2"/>
+          <a:stretch>
+            <a:fillRect/>
+          </a:stretch>
+        </p:blipFill>
+        <p:spPr>
+          <a:xfrm>
+            <a:off x="0" y="0"/>
+            <a:ext cx="4320000" cy="2160000"/>
+          </a:xfrm>
+          <a:prstGeom prst="rect">
+            <a:avLst/>
+          </a:prstGeom>
+        </p:spPr>
+      </p:pic>
+    </p:spTree>
+  </p:cSld>
+  <p:clrMapOvr>
+    <a:masterClrMapping/>
+  </p:clrMapOvr>
+</p:sld>
+</file>
+
+<file path=ppt/slides/slide35.xml><?xml version="1.0" encoding="utf-8"?>
+<p:sld xmlns:a="http://schemas.openxmlformats.org/drawingml/2006/main" xmlns:p="http://schemas.openxmlformats.org/presentationml/2006/main" xmlns:r="http://schemas.openxmlformats.org/officeDocument/2006/relationships">
+  <p:cSld>
+    <p:spTree>
+      <p:nvGrpSpPr>
+        <p:cNvPr id="1" name=""/>
+        <p:cNvGrpSpPr/>
+        <p:nvPr/>
+      </p:nvGrpSpPr>
+      <p:grpSpPr/>
+      <p:pic>
+        <p:nvPicPr>
+          <p:cNvPr id="2" name="Picture 1" descr="proc_argentina.png"/>
           <p:cNvPicPr>
             <a:picLocks noChangeAspect="1"/>
           </p:cNvPicPr>

</xml_diff>